<commit_message>
Daily dashboard refresh 2026-01-19 23:59
</commit_message>
<xml_diff>
--- a/data/Summary.pptx
+++ b/data/Summary.pptx
@@ -3189,12 +3189,12 @@
           <a:lstStyle/>
           <a:p>
             <a:r>
-              <a:t>Total Visits: 3980</a:t>
-            </a:r>
-          </a:p>
-          <a:p>
-            <a:r>
-              <a:t>Pass: 3843</a:t>
+              <a:t>Total Visits: 2237</a:t>
+            </a:r>
+          </a:p>
+          <a:p>
+            <a:r>
+              <a:t>Pass: 2100</a:t>
             </a:r>
           </a:p>
           <a:p>
@@ -3264,12 +3264,12 @@
           <a:lstStyle/>
           <a:p>
             <a:r>
-              <a:t>Total Visits: 929</a:t>
-            </a:r>
-          </a:p>
-          <a:p>
-            <a:r>
-              <a:t>Pass: 891</a:t>
+              <a:t>Total Visits: 489</a:t>
+            </a:r>
+          </a:p>
+          <a:p>
+            <a:r>
+              <a:t>Pass: 451</a:t>
             </a:r>
           </a:p>
           <a:p>
@@ -3318,7 +3318,7 @@
           <a:lstStyle/>
           <a:p>
             <a:r>
-              <a:t>East Region Summary</a:t>
+              <a:t>Central Region Summary</a:t>
             </a:r>
           </a:p>
         </p:txBody>
@@ -3339,17 +3339,17 @@
           <a:lstStyle/>
           <a:p>
             <a:r>
-              <a:t>Total Visits: 23</a:t>
-            </a:r>
-          </a:p>
-          <a:p>
-            <a:r>
-              <a:t>Pass: 0</a:t>
-            </a:r>
-          </a:p>
-          <a:p>
-            <a:r>
-              <a:t>Fail: 23</a:t>
+              <a:t>Total Visits: 64</a:t>
+            </a:r>
+          </a:p>
+          <a:p>
+            <a:r>
+              <a:t>Pass: 59</a:t>
+            </a:r>
+          </a:p>
+          <a:p>
+            <a:r>
+              <a:t>Fail: 5</a:t>
             </a:r>
           </a:p>
           <a:p>
@@ -3393,7 +3393,7 @@
           <a:lstStyle/>
           <a:p>
             <a:r>
-              <a:t>Central Region Summary</a:t>
+              <a:t>East Region Summary</a:t>
             </a:r>
           </a:p>
         </p:txBody>
@@ -3414,17 +3414,17 @@
           <a:lstStyle/>
           <a:p>
             <a:r>
-              <a:t>Total Visits: 88</a:t>
-            </a:r>
-          </a:p>
-          <a:p>
-            <a:r>
-              <a:t>Pass: 83</a:t>
-            </a:r>
-          </a:p>
-          <a:p>
-            <a:r>
-              <a:t>Fail: 5</a:t>
+              <a:t>Total Visits: 23</a:t>
+            </a:r>
+          </a:p>
+          <a:p>
+            <a:r>
+              <a:t>Pass: 0</a:t>
+            </a:r>
+          </a:p>
+          <a:p>
+            <a:r>
+              <a:t>Fail: 23</a:t>
             </a:r>
           </a:p>
           <a:p>

</xml_diff>

<commit_message>
Daily dashboard refresh 2026-01-20 01:46
</commit_message>
<xml_diff>
--- a/data/Summary.pptx
+++ b/data/Summary.pptx
@@ -9,7 +9,6 @@
     <p:sldId id="257" r:id="rId8"/>
     <p:sldId id="258" r:id="rId9"/>
     <p:sldId id="259" r:id="rId10"/>
-    <p:sldId id="260" r:id="rId11"/>
   </p:sldIdLst>
   <p:sldSz cx="9144000" cy="6858000" type="screen4x3"/>
   <p:notesSz cx="6858000" cy="9144000"/>
@@ -3189,17 +3188,17 @@
           <a:lstStyle/>
           <a:p>
             <a:r>
-              <a:t>Total Visits: 2237</a:t>
-            </a:r>
-          </a:p>
-          <a:p>
-            <a:r>
-              <a:t>Pass: 2100</a:t>
-            </a:r>
-          </a:p>
-          <a:p>
-            <a:r>
-              <a:t>Fail: 137</a:t>
+              <a:t>Total Visits: 2089</a:t>
+            </a:r>
+          </a:p>
+          <a:p>
+            <a:r>
+              <a:t>Pass: 2088</a:t>
+            </a:r>
+          </a:p>
+          <a:p>
+            <a:r>
+              <a:t>Fail: 1</a:t>
             </a:r>
           </a:p>
           <a:p>
@@ -3264,17 +3263,17 @@
           <a:lstStyle/>
           <a:p>
             <a:r>
-              <a:t>Total Visits: 489</a:t>
-            </a:r>
-          </a:p>
-          <a:p>
-            <a:r>
-              <a:t>Pass: 451</a:t>
-            </a:r>
-          </a:p>
-          <a:p>
-            <a:r>
-              <a:t>Fail: 38</a:t>
+              <a:t>Total Visits: 442</a:t>
+            </a:r>
+          </a:p>
+          <a:p>
+            <a:r>
+              <a:t>Pass: 442</a:t>
+            </a:r>
+          </a:p>
+          <a:p>
+            <a:r>
+              <a:t>Fail: 0</a:t>
             </a:r>
           </a:p>
           <a:p>
@@ -3339,92 +3338,17 @@
           <a:lstStyle/>
           <a:p>
             <a:r>
-              <a:t>Total Visits: 64</a:t>
-            </a:r>
-          </a:p>
-          <a:p>
-            <a:r>
-              <a:t>Pass: 59</a:t>
-            </a:r>
-          </a:p>
-          <a:p>
-            <a:r>
-              <a:t>Fail: 5</a:t>
-            </a:r>
-          </a:p>
-          <a:p>
-            <a:r>
-              <a:t>Exempted: 0</a:t>
-            </a:r>
-          </a:p>
-        </p:txBody>
-      </p:sp>
-    </p:spTree>
-  </p:cSld>
-  <p:clrMapOvr>
-    <a:masterClrMapping/>
-  </p:clrMapOvr>
-</p:sld>
-</file>
-
-<file path=ppt/slides/slide5.xml><?xml version="1.0" encoding="utf-8"?>
-<p:sld xmlns:a="http://schemas.openxmlformats.org/drawingml/2006/main" xmlns:p="http://schemas.openxmlformats.org/presentationml/2006/main" xmlns:r="http://schemas.openxmlformats.org/officeDocument/2006/relationships">
-  <p:cSld>
-    <p:spTree>
-      <p:nvGrpSpPr>
-        <p:cNvPr id="1" name=""/>
-        <p:cNvGrpSpPr/>
-        <p:nvPr/>
-      </p:nvGrpSpPr>
-      <p:grpSpPr/>
-      <p:sp>
-        <p:nvSpPr>
-          <p:cNvPr id="2" name="Title 1"/>
-          <p:cNvSpPr>
-            <a:spLocks noGrp="1"/>
-          </p:cNvSpPr>
-          <p:nvPr>
-            <p:ph type="title"/>
-          </p:nvPr>
-        </p:nvSpPr>
-        <p:spPr/>
-        <p:txBody>
-          <a:bodyPr/>
-          <a:lstStyle/>
-          <a:p>
-            <a:r>
-              <a:t>East Region Summary</a:t>
-            </a:r>
-          </a:p>
-        </p:txBody>
-      </p:sp>
-      <p:sp>
-        <p:nvSpPr>
-          <p:cNvPr id="3" name="Content Placeholder 2"/>
-          <p:cNvSpPr>
-            <a:spLocks noGrp="1"/>
-          </p:cNvSpPr>
-          <p:nvPr>
-            <p:ph idx="1"/>
-          </p:nvPr>
-        </p:nvSpPr>
-        <p:spPr/>
-        <p:txBody>
-          <a:bodyPr/>
-          <a:lstStyle/>
-          <a:p>
-            <a:r>
-              <a:t>Total Visits: 23</a:t>
-            </a:r>
-          </a:p>
-          <a:p>
-            <a:r>
-              <a:t>Pass: 0</a:t>
-            </a:r>
-          </a:p>
-          <a:p>
-            <a:r>
-              <a:t>Fail: 23</a:t>
+              <a:t>Total Visits: 53</a:t>
+            </a:r>
+          </a:p>
+          <a:p>
+            <a:r>
+              <a:t>Pass: 53</a:t>
+            </a:r>
+          </a:p>
+          <a:p>
+            <a:r>
+              <a:t>Fail: 0</a:t>
             </a:r>
           </a:p>
           <a:p>

</xml_diff>

<commit_message>
Daily dashboard refresh 2026-01-20 03:03
</commit_message>
<xml_diff>
--- a/data/Summary.pptx
+++ b/data/Summary.pptx
@@ -3242,7 +3242,7 @@
           <a:lstStyle/>
           <a:p>
             <a:r>
-              <a:t>South Region Summary</a:t>
+              <a:t>Central Region Summary</a:t>
             </a:r>
           </a:p>
         </p:txBody>
@@ -3263,12 +3263,12 @@
           <a:lstStyle/>
           <a:p>
             <a:r>
-              <a:t>Total Visits: 442</a:t>
-            </a:r>
-          </a:p>
-          <a:p>
-            <a:r>
-              <a:t>Pass: 442</a:t>
+              <a:t>Total Visits: 53</a:t>
+            </a:r>
+          </a:p>
+          <a:p>
+            <a:r>
+              <a:t>Pass: 53</a:t>
             </a:r>
           </a:p>
           <a:p>
@@ -3317,7 +3317,7 @@
           <a:lstStyle/>
           <a:p>
             <a:r>
-              <a:t>Central Region Summary</a:t>
+              <a:t>South Region Summary</a:t>
             </a:r>
           </a:p>
         </p:txBody>
@@ -3338,12 +3338,12 @@
           <a:lstStyle/>
           <a:p>
             <a:r>
-              <a:t>Total Visits: 53</a:t>
-            </a:r>
-          </a:p>
-          <a:p>
-            <a:r>
-              <a:t>Pass: 53</a:t>
+              <a:t>Total Visits: 442</a:t>
+            </a:r>
+          </a:p>
+          <a:p>
+            <a:r>
+              <a:t>Pass: 442</a:t>
             </a:r>
           </a:p>
           <a:p>

</xml_diff>

<commit_message>
Daily dashboard refresh 2026-01-21 07:00
</commit_message>
<xml_diff>
--- a/data/Summary.pptx
+++ b/data/Summary.pptx
@@ -3188,17 +3188,17 @@
           <a:lstStyle/>
           <a:p>
             <a:r>
-              <a:t>Total Visits: 2089</a:t>
-            </a:r>
-          </a:p>
-          <a:p>
-            <a:r>
-              <a:t>Pass: 2088</a:t>
-            </a:r>
-          </a:p>
-          <a:p>
-            <a:r>
-              <a:t>Fail: 1</a:t>
+              <a:t>Total Visits: 2096</a:t>
+            </a:r>
+          </a:p>
+          <a:p>
+            <a:r>
+              <a:t>Pass: 2094</a:t>
+            </a:r>
+          </a:p>
+          <a:p>
+            <a:r>
+              <a:t>Fail: 2</a:t>
             </a:r>
           </a:p>
           <a:p>
@@ -3338,12 +3338,12 @@
           <a:lstStyle/>
           <a:p>
             <a:r>
-              <a:t>Total Visits: 442</a:t>
-            </a:r>
-          </a:p>
-          <a:p>
-            <a:r>
-              <a:t>Pass: 442</a:t>
+              <a:t>Total Visits: 449</a:t>
+            </a:r>
+          </a:p>
+          <a:p>
+            <a:r>
+              <a:t>Pass: 449</a:t>
             </a:r>
           </a:p>
           <a:p>

</xml_diff>

<commit_message>
Daily dashboard refresh 2026-01-22 07:00
</commit_message>
<xml_diff>
--- a/data/Summary.pptx
+++ b/data/Summary.pptx
@@ -3188,12 +3188,12 @@
           <a:lstStyle/>
           <a:p>
             <a:r>
-              <a:t>Total Visits: 2096</a:t>
-            </a:r>
-          </a:p>
-          <a:p>
-            <a:r>
-              <a:t>Pass: 2094</a:t>
+              <a:t>Total Visits: 2101</a:t>
+            </a:r>
+          </a:p>
+          <a:p>
+            <a:r>
+              <a:t>Pass: 2099</a:t>
             </a:r>
           </a:p>
           <a:p>
@@ -3338,12 +3338,12 @@
           <a:lstStyle/>
           <a:p>
             <a:r>
-              <a:t>Total Visits: 449</a:t>
-            </a:r>
-          </a:p>
-          <a:p>
-            <a:r>
-              <a:t>Pass: 449</a:t>
+              <a:t>Total Visits: 451</a:t>
+            </a:r>
+          </a:p>
+          <a:p>
+            <a:r>
+              <a:t>Pass: 451</a:t>
             </a:r>
           </a:p>
           <a:p>

</xml_diff>